<commit_message>
Update (宣道詩284)主由墳墓裡復活Christ Phục Sinh.pptx
</commit_message>
<xml_diff>
--- a/中越詩歌/(宣道詩284)主由墳墓裡復活Christ Phục Sinh.pptx
+++ b/中越詩歌/(宣道詩284)主由墳墓裡復活Christ Phục Sinh.pptx
@@ -185,7 +185,7 @@
           <a:lstStyle/>
           <a:p>
             <a:r>
-              <a:rPr lang="en-US" altLang="zh-TW" smtClean="0"/>
+              <a:rPr lang="en-US" altLang="zh-TW"/>
               <a:t>Click to edit Master title style</a:t>
             </a:r>
             <a:endParaRPr lang="zh-TW" altLang="en-US"/>
@@ -304,7 +304,7 @@
           </a:lstStyle>
           <a:p>
             <a:r>
-              <a:rPr lang="en-US" altLang="zh-TW" smtClean="0"/>
+              <a:rPr lang="en-US" altLang="zh-TW"/>
               <a:t>Click to edit Master subtitle style</a:t>
             </a:r>
             <a:endParaRPr lang="zh-TW" altLang="en-US"/>
@@ -329,7 +329,7 @@
             <a:fld id="{39791B63-5384-4D93-BE21-63F47D41B8DE}" type="datetimeFigureOut">
               <a:rPr lang="zh-TW" altLang="en-US" smtClean="0"/>
               <a:pPr/>
-              <a:t>2022/4/16</a:t>
+              <a:t>2025/4/19</a:t>
             </a:fld>
             <a:endParaRPr lang="zh-TW" altLang="en-US"/>
           </a:p>
@@ -424,7 +424,7 @@
           <a:lstStyle/>
           <a:p>
             <a:r>
-              <a:rPr lang="en-US" altLang="zh-TW" smtClean="0"/>
+              <a:rPr lang="en-US" altLang="zh-TW"/>
               <a:t>Click to edit Master title style</a:t>
             </a:r>
             <a:endParaRPr lang="zh-TW" altLang="en-US"/>
@@ -448,35 +448,35 @@
           <a:p>
             <a:pPr lvl="0"/>
             <a:r>
-              <a:rPr lang="en-US" altLang="zh-TW" smtClean="0"/>
+              <a:rPr lang="en-US" altLang="zh-TW"/>
               <a:t>Edit Master text styles</a:t>
             </a:r>
           </a:p>
           <a:p>
             <a:pPr lvl="1"/>
             <a:r>
-              <a:rPr lang="en-US" altLang="zh-TW" smtClean="0"/>
+              <a:rPr lang="en-US" altLang="zh-TW"/>
               <a:t>Second level</a:t>
             </a:r>
           </a:p>
           <a:p>
             <a:pPr lvl="2"/>
             <a:r>
-              <a:rPr lang="en-US" altLang="zh-TW" smtClean="0"/>
+              <a:rPr lang="en-US" altLang="zh-TW"/>
               <a:t>Third level</a:t>
             </a:r>
           </a:p>
           <a:p>
             <a:pPr lvl="3"/>
             <a:r>
-              <a:rPr lang="en-US" altLang="zh-TW" smtClean="0"/>
+              <a:rPr lang="en-US" altLang="zh-TW"/>
               <a:t>Fourth level</a:t>
             </a:r>
           </a:p>
           <a:p>
             <a:pPr lvl="4"/>
             <a:r>
-              <a:rPr lang="en-US" altLang="zh-TW" smtClean="0"/>
+              <a:rPr lang="en-US" altLang="zh-TW"/>
               <a:t>Fifth level</a:t>
             </a:r>
             <a:endParaRPr lang="zh-TW" altLang="en-US"/>
@@ -501,7 +501,7 @@
             <a:fld id="{39791B63-5384-4D93-BE21-63F47D41B8DE}" type="datetimeFigureOut">
               <a:rPr lang="zh-TW" altLang="en-US" smtClean="0"/>
               <a:pPr/>
-              <a:t>2022/4/16</a:t>
+              <a:t>2025/4/19</a:t>
             </a:fld>
             <a:endParaRPr lang="zh-TW" altLang="en-US"/>
           </a:p>
@@ -601,7 +601,7 @@
           <a:lstStyle/>
           <a:p>
             <a:r>
-              <a:rPr lang="en-US" altLang="zh-TW" smtClean="0"/>
+              <a:rPr lang="en-US" altLang="zh-TW"/>
               <a:t>Click to edit Master title style</a:t>
             </a:r>
             <a:endParaRPr lang="zh-TW" altLang="en-US"/>
@@ -630,35 +630,35 @@
           <a:p>
             <a:pPr lvl="0"/>
             <a:r>
-              <a:rPr lang="en-US" altLang="zh-TW" smtClean="0"/>
+              <a:rPr lang="en-US" altLang="zh-TW"/>
               <a:t>Edit Master text styles</a:t>
             </a:r>
           </a:p>
           <a:p>
             <a:pPr lvl="1"/>
             <a:r>
-              <a:rPr lang="en-US" altLang="zh-TW" smtClean="0"/>
+              <a:rPr lang="en-US" altLang="zh-TW"/>
               <a:t>Second level</a:t>
             </a:r>
           </a:p>
           <a:p>
             <a:pPr lvl="2"/>
             <a:r>
-              <a:rPr lang="en-US" altLang="zh-TW" smtClean="0"/>
+              <a:rPr lang="en-US" altLang="zh-TW"/>
               <a:t>Third level</a:t>
             </a:r>
           </a:p>
           <a:p>
             <a:pPr lvl="3"/>
             <a:r>
-              <a:rPr lang="en-US" altLang="zh-TW" smtClean="0"/>
+              <a:rPr lang="en-US" altLang="zh-TW"/>
               <a:t>Fourth level</a:t>
             </a:r>
           </a:p>
           <a:p>
             <a:pPr lvl="4"/>
             <a:r>
-              <a:rPr lang="en-US" altLang="zh-TW" smtClean="0"/>
+              <a:rPr lang="en-US" altLang="zh-TW"/>
               <a:t>Fifth level</a:t>
             </a:r>
             <a:endParaRPr lang="zh-TW" altLang="en-US"/>
@@ -683,7 +683,7 @@
             <a:fld id="{39791B63-5384-4D93-BE21-63F47D41B8DE}" type="datetimeFigureOut">
               <a:rPr lang="zh-TW" altLang="en-US" smtClean="0"/>
               <a:pPr/>
-              <a:t>2022/4/16</a:t>
+              <a:t>2025/4/19</a:t>
             </a:fld>
             <a:endParaRPr lang="zh-TW" altLang="en-US"/>
           </a:p>
@@ -778,7 +778,7 @@
           <a:lstStyle/>
           <a:p>
             <a:r>
-              <a:rPr lang="en-US" altLang="zh-TW" smtClean="0"/>
+              <a:rPr lang="en-US" altLang="zh-TW"/>
               <a:t>Click to edit Master title style</a:t>
             </a:r>
             <a:endParaRPr lang="zh-TW" altLang="en-US"/>
@@ -802,35 +802,35 @@
           <a:p>
             <a:pPr lvl="0"/>
             <a:r>
-              <a:rPr lang="en-US" altLang="zh-TW" smtClean="0"/>
+              <a:rPr lang="en-US" altLang="zh-TW"/>
               <a:t>Edit Master text styles</a:t>
             </a:r>
           </a:p>
           <a:p>
             <a:pPr lvl="1"/>
             <a:r>
-              <a:rPr lang="en-US" altLang="zh-TW" smtClean="0"/>
+              <a:rPr lang="en-US" altLang="zh-TW"/>
               <a:t>Second level</a:t>
             </a:r>
           </a:p>
           <a:p>
             <a:pPr lvl="2"/>
             <a:r>
-              <a:rPr lang="en-US" altLang="zh-TW" smtClean="0"/>
+              <a:rPr lang="en-US" altLang="zh-TW"/>
               <a:t>Third level</a:t>
             </a:r>
           </a:p>
           <a:p>
             <a:pPr lvl="3"/>
             <a:r>
-              <a:rPr lang="en-US" altLang="zh-TW" smtClean="0"/>
+              <a:rPr lang="en-US" altLang="zh-TW"/>
               <a:t>Fourth level</a:t>
             </a:r>
           </a:p>
           <a:p>
             <a:pPr lvl="4"/>
             <a:r>
-              <a:rPr lang="en-US" altLang="zh-TW" smtClean="0"/>
+              <a:rPr lang="en-US" altLang="zh-TW"/>
               <a:t>Fifth level</a:t>
             </a:r>
             <a:endParaRPr lang="zh-TW" altLang="en-US"/>
@@ -855,7 +855,7 @@
             <a:fld id="{39791B63-5384-4D93-BE21-63F47D41B8DE}" type="datetimeFigureOut">
               <a:rPr lang="zh-TW" altLang="en-US" smtClean="0"/>
               <a:pPr/>
-              <a:t>2022/4/16</a:t>
+              <a:t>2025/4/19</a:t>
             </a:fld>
             <a:endParaRPr lang="zh-TW" altLang="en-US"/>
           </a:p>
@@ -959,7 +959,7 @@
           </a:lstStyle>
           <a:p>
             <a:r>
-              <a:rPr lang="en-US" altLang="zh-TW" smtClean="0"/>
+              <a:rPr lang="en-US" altLang="zh-TW"/>
               <a:t>Click to edit Master title style</a:t>
             </a:r>
             <a:endParaRPr lang="zh-TW" altLang="en-US"/>
@@ -1079,7 +1079,7 @@
           <a:p>
             <a:pPr lvl="0"/>
             <a:r>
-              <a:rPr lang="en-US" altLang="zh-TW" smtClean="0"/>
+              <a:rPr lang="en-US" altLang="zh-TW"/>
               <a:t>Edit Master text styles</a:t>
             </a:r>
           </a:p>
@@ -1103,7 +1103,7 @@
             <a:fld id="{39791B63-5384-4D93-BE21-63F47D41B8DE}" type="datetimeFigureOut">
               <a:rPr lang="zh-TW" altLang="en-US" smtClean="0"/>
               <a:pPr/>
-              <a:t>2022/4/16</a:t>
+              <a:t>2025/4/19</a:t>
             </a:fld>
             <a:endParaRPr lang="zh-TW" altLang="en-US"/>
           </a:p>
@@ -1198,7 +1198,7 @@
           <a:lstStyle/>
           <a:p>
             <a:r>
-              <a:rPr lang="en-US" altLang="zh-TW" smtClean="0"/>
+              <a:rPr lang="en-US" altLang="zh-TW"/>
               <a:t>Click to edit Master title style</a:t>
             </a:r>
             <a:endParaRPr lang="zh-TW" altLang="en-US"/>
@@ -1255,35 +1255,35 @@
           <a:p>
             <a:pPr lvl="0"/>
             <a:r>
-              <a:rPr lang="en-US" altLang="zh-TW" smtClean="0"/>
+              <a:rPr lang="en-US" altLang="zh-TW"/>
               <a:t>Edit Master text styles</a:t>
             </a:r>
           </a:p>
           <a:p>
             <a:pPr lvl="1"/>
             <a:r>
-              <a:rPr lang="en-US" altLang="zh-TW" smtClean="0"/>
+              <a:rPr lang="en-US" altLang="zh-TW"/>
               <a:t>Second level</a:t>
             </a:r>
           </a:p>
           <a:p>
             <a:pPr lvl="2"/>
             <a:r>
-              <a:rPr lang="en-US" altLang="zh-TW" smtClean="0"/>
+              <a:rPr lang="en-US" altLang="zh-TW"/>
               <a:t>Third level</a:t>
             </a:r>
           </a:p>
           <a:p>
             <a:pPr lvl="3"/>
             <a:r>
-              <a:rPr lang="en-US" altLang="zh-TW" smtClean="0"/>
+              <a:rPr lang="en-US" altLang="zh-TW"/>
               <a:t>Fourth level</a:t>
             </a:r>
           </a:p>
           <a:p>
             <a:pPr lvl="4"/>
             <a:r>
-              <a:rPr lang="en-US" altLang="zh-TW" smtClean="0"/>
+              <a:rPr lang="en-US" altLang="zh-TW"/>
               <a:t>Fifth level</a:t>
             </a:r>
             <a:endParaRPr lang="zh-TW" altLang="en-US"/>
@@ -1340,35 +1340,35 @@
           <a:p>
             <a:pPr lvl="0"/>
             <a:r>
-              <a:rPr lang="en-US" altLang="zh-TW" smtClean="0"/>
+              <a:rPr lang="en-US" altLang="zh-TW"/>
               <a:t>Edit Master text styles</a:t>
             </a:r>
           </a:p>
           <a:p>
             <a:pPr lvl="1"/>
             <a:r>
-              <a:rPr lang="en-US" altLang="zh-TW" smtClean="0"/>
+              <a:rPr lang="en-US" altLang="zh-TW"/>
               <a:t>Second level</a:t>
             </a:r>
           </a:p>
           <a:p>
             <a:pPr lvl="2"/>
             <a:r>
-              <a:rPr lang="en-US" altLang="zh-TW" smtClean="0"/>
+              <a:rPr lang="en-US" altLang="zh-TW"/>
               <a:t>Third level</a:t>
             </a:r>
           </a:p>
           <a:p>
             <a:pPr lvl="3"/>
             <a:r>
-              <a:rPr lang="en-US" altLang="zh-TW" smtClean="0"/>
+              <a:rPr lang="en-US" altLang="zh-TW"/>
               <a:t>Fourth level</a:t>
             </a:r>
           </a:p>
           <a:p>
             <a:pPr lvl="4"/>
             <a:r>
-              <a:rPr lang="en-US" altLang="zh-TW" smtClean="0"/>
+              <a:rPr lang="en-US" altLang="zh-TW"/>
               <a:t>Fifth level</a:t>
             </a:r>
             <a:endParaRPr lang="zh-TW" altLang="en-US"/>
@@ -1393,7 +1393,7 @@
             <a:fld id="{39791B63-5384-4D93-BE21-63F47D41B8DE}" type="datetimeFigureOut">
               <a:rPr lang="zh-TW" altLang="en-US" smtClean="0"/>
               <a:pPr/>
-              <a:t>2022/4/16</a:t>
+              <a:t>2025/4/19</a:t>
             </a:fld>
             <a:endParaRPr lang="zh-TW" altLang="en-US"/>
           </a:p>
@@ -1492,7 +1492,7 @@
           </a:lstStyle>
           <a:p>
             <a:r>
-              <a:rPr lang="en-US" altLang="zh-TW" smtClean="0"/>
+              <a:rPr lang="en-US" altLang="zh-TW"/>
               <a:t>Click to edit Master title style</a:t>
             </a:r>
             <a:endParaRPr lang="zh-TW" altLang="en-US"/>
@@ -1558,7 +1558,7 @@
           <a:p>
             <a:pPr lvl="0"/>
             <a:r>
-              <a:rPr lang="en-US" altLang="zh-TW" smtClean="0"/>
+              <a:rPr lang="en-US" altLang="zh-TW"/>
               <a:t>Edit Master text styles</a:t>
             </a:r>
           </a:p>
@@ -1614,35 +1614,35 @@
           <a:p>
             <a:pPr lvl="0"/>
             <a:r>
-              <a:rPr lang="en-US" altLang="zh-TW" smtClean="0"/>
+              <a:rPr lang="en-US" altLang="zh-TW"/>
               <a:t>Edit Master text styles</a:t>
             </a:r>
           </a:p>
           <a:p>
             <a:pPr lvl="1"/>
             <a:r>
-              <a:rPr lang="en-US" altLang="zh-TW" smtClean="0"/>
+              <a:rPr lang="en-US" altLang="zh-TW"/>
               <a:t>Second level</a:t>
             </a:r>
           </a:p>
           <a:p>
             <a:pPr lvl="2"/>
             <a:r>
-              <a:rPr lang="en-US" altLang="zh-TW" smtClean="0"/>
+              <a:rPr lang="en-US" altLang="zh-TW"/>
               <a:t>Third level</a:t>
             </a:r>
           </a:p>
           <a:p>
             <a:pPr lvl="3"/>
             <a:r>
-              <a:rPr lang="en-US" altLang="zh-TW" smtClean="0"/>
+              <a:rPr lang="en-US" altLang="zh-TW"/>
               <a:t>Fourth level</a:t>
             </a:r>
           </a:p>
           <a:p>
             <a:pPr lvl="4"/>
             <a:r>
-              <a:rPr lang="en-US" altLang="zh-TW" smtClean="0"/>
+              <a:rPr lang="en-US" altLang="zh-TW"/>
               <a:t>Fifth level</a:t>
             </a:r>
             <a:endParaRPr lang="zh-TW" altLang="en-US"/>
@@ -1708,7 +1708,7 @@
           <a:p>
             <a:pPr lvl="0"/>
             <a:r>
-              <a:rPr lang="en-US" altLang="zh-TW" smtClean="0"/>
+              <a:rPr lang="en-US" altLang="zh-TW"/>
               <a:t>Edit Master text styles</a:t>
             </a:r>
           </a:p>
@@ -1764,35 +1764,35 @@
           <a:p>
             <a:pPr lvl="0"/>
             <a:r>
-              <a:rPr lang="en-US" altLang="zh-TW" smtClean="0"/>
+              <a:rPr lang="en-US" altLang="zh-TW"/>
               <a:t>Edit Master text styles</a:t>
             </a:r>
           </a:p>
           <a:p>
             <a:pPr lvl="1"/>
             <a:r>
-              <a:rPr lang="en-US" altLang="zh-TW" smtClean="0"/>
+              <a:rPr lang="en-US" altLang="zh-TW"/>
               <a:t>Second level</a:t>
             </a:r>
           </a:p>
           <a:p>
             <a:pPr lvl="2"/>
             <a:r>
-              <a:rPr lang="en-US" altLang="zh-TW" smtClean="0"/>
+              <a:rPr lang="en-US" altLang="zh-TW"/>
               <a:t>Third level</a:t>
             </a:r>
           </a:p>
           <a:p>
             <a:pPr lvl="3"/>
             <a:r>
-              <a:rPr lang="en-US" altLang="zh-TW" smtClean="0"/>
+              <a:rPr lang="en-US" altLang="zh-TW"/>
               <a:t>Fourth level</a:t>
             </a:r>
           </a:p>
           <a:p>
             <a:pPr lvl="4"/>
             <a:r>
-              <a:rPr lang="en-US" altLang="zh-TW" smtClean="0"/>
+              <a:rPr lang="en-US" altLang="zh-TW"/>
               <a:t>Fifth level</a:t>
             </a:r>
             <a:endParaRPr lang="zh-TW" altLang="en-US"/>
@@ -1817,7 +1817,7 @@
             <a:fld id="{39791B63-5384-4D93-BE21-63F47D41B8DE}" type="datetimeFigureOut">
               <a:rPr lang="zh-TW" altLang="en-US" smtClean="0"/>
               <a:pPr/>
-              <a:t>2022/4/16</a:t>
+              <a:t>2025/4/19</a:t>
             </a:fld>
             <a:endParaRPr lang="zh-TW" altLang="en-US"/>
           </a:p>
@@ -1912,7 +1912,7 @@
           <a:lstStyle/>
           <a:p>
             <a:r>
-              <a:rPr lang="en-US" altLang="zh-TW" smtClean="0"/>
+              <a:rPr lang="en-US" altLang="zh-TW"/>
               <a:t>Click to edit Master title style</a:t>
             </a:r>
             <a:endParaRPr lang="zh-TW" altLang="en-US"/>
@@ -1937,7 +1937,7 @@
             <a:fld id="{39791B63-5384-4D93-BE21-63F47D41B8DE}" type="datetimeFigureOut">
               <a:rPr lang="zh-TW" altLang="en-US" smtClean="0"/>
               <a:pPr/>
-              <a:t>2022/4/16</a:t>
+              <a:t>2025/4/19</a:t>
             </a:fld>
             <a:endParaRPr lang="zh-TW" altLang="en-US"/>
           </a:p>
@@ -2034,7 +2034,7 @@
             <a:fld id="{39791B63-5384-4D93-BE21-63F47D41B8DE}" type="datetimeFigureOut">
               <a:rPr lang="zh-TW" altLang="en-US" smtClean="0"/>
               <a:pPr/>
-              <a:t>2022/4/16</a:t>
+              <a:t>2025/4/19</a:t>
             </a:fld>
             <a:endParaRPr lang="zh-TW" altLang="en-US"/>
           </a:p>
@@ -2138,7 +2138,7 @@
           </a:lstStyle>
           <a:p>
             <a:r>
-              <a:rPr lang="en-US" altLang="zh-TW" smtClean="0"/>
+              <a:rPr lang="en-US" altLang="zh-TW"/>
               <a:t>Click to edit Master title style</a:t>
             </a:r>
             <a:endParaRPr lang="zh-TW" altLang="en-US"/>
@@ -2195,35 +2195,35 @@
           <a:p>
             <a:pPr lvl="0"/>
             <a:r>
-              <a:rPr lang="en-US" altLang="zh-TW" smtClean="0"/>
+              <a:rPr lang="en-US" altLang="zh-TW"/>
               <a:t>Edit Master text styles</a:t>
             </a:r>
           </a:p>
           <a:p>
             <a:pPr lvl="1"/>
             <a:r>
-              <a:rPr lang="en-US" altLang="zh-TW" smtClean="0"/>
+              <a:rPr lang="en-US" altLang="zh-TW"/>
               <a:t>Second level</a:t>
             </a:r>
           </a:p>
           <a:p>
             <a:pPr lvl="2"/>
             <a:r>
-              <a:rPr lang="en-US" altLang="zh-TW" smtClean="0"/>
+              <a:rPr lang="en-US" altLang="zh-TW"/>
               <a:t>Third level</a:t>
             </a:r>
           </a:p>
           <a:p>
             <a:pPr lvl="3"/>
             <a:r>
-              <a:rPr lang="en-US" altLang="zh-TW" smtClean="0"/>
+              <a:rPr lang="en-US" altLang="zh-TW"/>
               <a:t>Fourth level</a:t>
             </a:r>
           </a:p>
           <a:p>
             <a:pPr lvl="4"/>
             <a:r>
-              <a:rPr lang="en-US" altLang="zh-TW" smtClean="0"/>
+              <a:rPr lang="en-US" altLang="zh-TW"/>
               <a:t>Fifth level</a:t>
             </a:r>
             <a:endParaRPr lang="zh-TW" altLang="en-US"/>
@@ -2289,7 +2289,7 @@
           <a:p>
             <a:pPr lvl="0"/>
             <a:r>
-              <a:rPr lang="en-US" altLang="zh-TW" smtClean="0"/>
+              <a:rPr lang="en-US" altLang="zh-TW"/>
               <a:t>Edit Master text styles</a:t>
             </a:r>
           </a:p>
@@ -2313,7 +2313,7 @@
             <a:fld id="{39791B63-5384-4D93-BE21-63F47D41B8DE}" type="datetimeFigureOut">
               <a:rPr lang="zh-TW" altLang="en-US" smtClean="0"/>
               <a:pPr/>
-              <a:t>2022/4/16</a:t>
+              <a:t>2025/4/19</a:t>
             </a:fld>
             <a:endParaRPr lang="zh-TW" altLang="en-US"/>
           </a:p>
@@ -2417,7 +2417,7 @@
           </a:lstStyle>
           <a:p>
             <a:r>
-              <a:rPr lang="en-US" altLang="zh-TW" smtClean="0"/>
+              <a:rPr lang="en-US" altLang="zh-TW"/>
               <a:t>Click to edit Master title style</a:t>
             </a:r>
             <a:endParaRPr lang="zh-TW" altLang="en-US"/>
@@ -2482,7 +2482,7 @@
           </a:lstStyle>
           <a:p>
             <a:r>
-              <a:rPr lang="en-US" altLang="zh-TW" smtClean="0"/>
+              <a:rPr lang="en-US" altLang="zh-TW"/>
               <a:t>Click icon to add picture</a:t>
             </a:r>
             <a:endParaRPr lang="zh-TW" altLang="en-US"/>
@@ -2548,7 +2548,7 @@
           <a:p>
             <a:pPr lvl="0"/>
             <a:r>
-              <a:rPr lang="en-US" altLang="zh-TW" smtClean="0"/>
+              <a:rPr lang="en-US" altLang="zh-TW"/>
               <a:t>Edit Master text styles</a:t>
             </a:r>
           </a:p>
@@ -2572,7 +2572,7 @@
             <a:fld id="{39791B63-5384-4D93-BE21-63F47D41B8DE}" type="datetimeFigureOut">
               <a:rPr lang="zh-TW" altLang="en-US" smtClean="0"/>
               <a:pPr/>
-              <a:t>2022/4/16</a:t>
+              <a:t>2025/4/19</a:t>
             </a:fld>
             <a:endParaRPr lang="zh-TW" altLang="en-US"/>
           </a:p>
@@ -2687,10 +2687,9 @@
           <a:lstStyle/>
           <a:p>
             <a:r>
-              <a:rPr lang="zh-TW" altLang="en-US" smtClean="0"/>
+              <a:rPr lang="zh-TW" altLang="en-US"/>
               <a:t>按一下以編輯母片標題樣式</a:t>
             </a:r>
-            <a:endParaRPr lang="zh-TW" altLang="en-US"/>
           </a:p>
         </p:txBody>
       </p:sp>
@@ -2721,38 +2720,37 @@
           <a:p>
             <a:pPr lvl="0"/>
             <a:r>
-              <a:rPr lang="zh-TW" altLang="en-US" smtClean="0"/>
+              <a:rPr lang="zh-TW" altLang="en-US"/>
               <a:t>按一下以編輯母片文字樣式</a:t>
             </a:r>
           </a:p>
           <a:p>
             <a:pPr lvl="1"/>
             <a:r>
-              <a:rPr lang="zh-TW" altLang="en-US" smtClean="0"/>
+              <a:rPr lang="zh-TW" altLang="en-US"/>
               <a:t>第二層</a:t>
             </a:r>
           </a:p>
           <a:p>
             <a:pPr lvl="2"/>
             <a:r>
-              <a:rPr lang="zh-TW" altLang="en-US" smtClean="0"/>
+              <a:rPr lang="zh-TW" altLang="en-US"/>
               <a:t>第三層</a:t>
             </a:r>
           </a:p>
           <a:p>
             <a:pPr lvl="3"/>
             <a:r>
-              <a:rPr lang="zh-TW" altLang="en-US" smtClean="0"/>
+              <a:rPr lang="zh-TW" altLang="en-US"/>
               <a:t>第四層</a:t>
             </a:r>
           </a:p>
           <a:p>
             <a:pPr lvl="4"/>
             <a:r>
-              <a:rPr lang="zh-TW" altLang="en-US" smtClean="0"/>
+              <a:rPr lang="zh-TW" altLang="en-US"/>
               <a:t>第五層</a:t>
             </a:r>
-            <a:endParaRPr lang="zh-TW" altLang="en-US"/>
           </a:p>
         </p:txBody>
       </p:sp>
@@ -2792,7 +2790,7 @@
             <a:fld id="{39791B63-5384-4D93-BE21-63F47D41B8DE}" type="datetimeFigureOut">
               <a:rPr lang="zh-TW" altLang="en-US" smtClean="0"/>
               <a:pPr/>
-              <a:t>2022/4/16</a:t>
+              <a:t>2025/4/19</a:t>
             </a:fld>
             <a:endParaRPr lang="zh-TW" altLang="en-US"/>
           </a:p>
@@ -3191,7 +3189,7 @@
           <a:lstStyle/>
           <a:p>
             <a:r>
-              <a:rPr lang="zh-TW" altLang="en-US" sz="7200" b="1" i="1" dirty="0">
+              <a:rPr lang="zh-CN" altLang="en-US" sz="5400" b="1" i="1" dirty="0">
                 <a:solidFill>
                   <a:srgbClr val="000066"/>
                 </a:solidFill>
@@ -3205,10 +3203,10 @@
                 <a:latin typeface="微軟正黑體" pitchFamily="34" charset="-120"/>
                 <a:ea typeface="微軟正黑體" pitchFamily="34" charset="-120"/>
               </a:rPr>
-              <a:t>主</a:t>
-            </a:r>
-            <a:r>
-              <a:rPr lang="zh-TW" altLang="en-US" sz="7200" b="1" i="1" dirty="0">
+              <a:t>宣 </a:t>
+            </a:r>
+            <a:r>
+              <a:rPr lang="en-US" altLang="zh-CN" sz="5400" b="1" i="1" dirty="0">
                 <a:solidFill>
                   <a:srgbClr val="000066"/>
                 </a:solidFill>
@@ -3222,7 +3220,41 @@
                 <a:latin typeface="微軟正黑體" pitchFamily="34" charset="-120"/>
                 <a:ea typeface="微軟正黑體" pitchFamily="34" charset="-120"/>
               </a:rPr>
-              <a:t>由墳墓裡復活</a:t>
+              <a:t>284</a:t>
+            </a:r>
+            <a:r>
+              <a:rPr lang="en-US" altLang="zh-CN" sz="7200" b="1" i="1" dirty="0">
+                <a:solidFill>
+                  <a:srgbClr val="000066"/>
+                </a:solidFill>
+                <a:effectLst>
+                  <a:outerShdw blurRad="38100" dist="38100" dir="2700000" algn="tl">
+                    <a:srgbClr val="000000">
+                      <a:alpha val="43137"/>
+                    </a:srgbClr>
+                  </a:outerShdw>
+                </a:effectLst>
+                <a:latin typeface="微軟正黑體" pitchFamily="34" charset="-120"/>
+                <a:ea typeface="微軟正黑體" pitchFamily="34" charset="-120"/>
+              </a:rPr>
+              <a:t> - </a:t>
+            </a:r>
+            <a:r>
+              <a:rPr lang="zh-TW" altLang="en-US" sz="7200" b="1" i="1" dirty="0">
+                <a:solidFill>
+                  <a:srgbClr val="000066"/>
+                </a:solidFill>
+                <a:effectLst>
+                  <a:outerShdw blurRad="38100" dist="38100" dir="2700000" algn="tl">
+                    <a:srgbClr val="000000">
+                      <a:alpha val="43137"/>
+                    </a:srgbClr>
+                  </a:outerShdw>
+                </a:effectLst>
+                <a:latin typeface="微軟正黑體" pitchFamily="34" charset="-120"/>
+                <a:ea typeface="微軟正黑體" pitchFamily="34" charset="-120"/>
+              </a:rPr>
+              <a:t>主由墳墓裡復活</a:t>
             </a:r>
           </a:p>
         </p:txBody>
@@ -3281,25 +3313,7 @@
                 <a:ea typeface="微軟正黑體" pitchFamily="34" charset="-120"/>
                 <a:cs typeface="Calibri" panose="020F0502020204030204" pitchFamily="34" charset="0"/>
               </a:rPr>
-              <a:t>CHRIST </a:t>
-            </a:r>
-            <a:r>
-              <a:rPr lang="en-US" altLang="zh-TW" sz="5400" b="1" i="1" dirty="0">
-                <a:solidFill>
-                  <a:srgbClr val="660033"/>
-                </a:solidFill>
-                <a:effectLst>
-                  <a:outerShdw blurRad="38100" dist="38100" dir="2700000" algn="tl">
-                    <a:srgbClr val="000000">
-                      <a:alpha val="43137"/>
-                    </a:srgbClr>
-                  </a:outerShdw>
-                </a:effectLst>
-                <a:latin typeface="Calibri" panose="020F0502020204030204" pitchFamily="34" charset="0"/>
-                <a:ea typeface="微軟正黑體" pitchFamily="34" charset="-120"/>
-                <a:cs typeface="Calibri" panose="020F0502020204030204" pitchFamily="34" charset="0"/>
-              </a:rPr>
-              <a:t>PHỤC SINH</a:t>
+              <a:t>CHRIST PHỤC SINH (TC 103)</a:t>
             </a:r>
             <a:endParaRPr lang="zh-TW" altLang="en-US" sz="5400" b="1" i="1" dirty="0">
               <a:solidFill>
@@ -3382,27 +3396,7 @@
                 <a:latin typeface="微軟正黑體"/>
                 <a:ea typeface="微軟正黑體"/>
               </a:rPr>
-              <a:t>兵丁守墓無</a:t>
-            </a:r>
-            <a:r>
-              <a:rPr lang="zh-TW" altLang="en-US" sz="6400" b="1" spc="-1" dirty="0">
-                <a:solidFill>
-                  <a:srgbClr val="000066"/>
-                </a:solidFill>
-                <a:latin typeface="微軟正黑體"/>
-                <a:ea typeface="微軟正黑體"/>
-              </a:rPr>
-              <a:t>用   耶</a:t>
-            </a:r>
-            <a:r>
-              <a:rPr lang="zh-TW" altLang="en-US" sz="6400" b="1" spc="-1" dirty="0">
-                <a:solidFill>
-                  <a:srgbClr val="000066"/>
-                </a:solidFill>
-                <a:latin typeface="微軟正黑體"/>
-                <a:ea typeface="微軟正黑體"/>
-              </a:rPr>
-              <a:t>穌我救主</a:t>
+              <a:t>兵丁守墓無用   耶穌我救主</a:t>
             </a:r>
             <a:endParaRPr lang="en-US" altLang="zh-CN" sz="6400" b="1" spc="-1" dirty="0">
               <a:solidFill>
@@ -3589,25 +3583,7 @@
                 </a:solidFill>
                 <a:cs typeface="Arial" panose="020B0604020202020204" pitchFamily="34" charset="0"/>
               </a:rPr>
-              <a:t>Niêm phong mả Chúa dư </a:t>
-            </a:r>
-            <a:r>
-              <a:rPr lang="vi-VN" sz="3733" b="1" spc="-1" dirty="0">
-                <a:solidFill>
-                  <a:srgbClr val="660033"/>
-                </a:solidFill>
-                <a:cs typeface="Arial" panose="020B0604020202020204" pitchFamily="34" charset="0"/>
-              </a:rPr>
-              <a:t>công, Jesus </a:t>
-            </a:r>
-            <a:r>
-              <a:rPr lang="vi-VN" sz="3733" b="1" spc="-1" dirty="0">
-                <a:solidFill>
-                  <a:srgbClr val="660033"/>
-                </a:solidFill>
-                <a:cs typeface="Arial" panose="020B0604020202020204" pitchFamily="34" charset="0"/>
-              </a:rPr>
-              <a:t>Cứu Chúa tôi</a:t>
+              <a:t>Niêm phong mả Chúa dư công, Jesus Cứu Chúa tôi</a:t>
             </a:r>
           </a:p>
         </p:txBody>
@@ -3642,43 +3618,7 @@
                 </a:solidFill>
                 <a:effectLst/>
               </a:rPr>
-              <a:t>( </a:t>
-            </a:r>
-            <a:r>
-              <a:rPr lang="en-US" sz="4267" b="1" dirty="0">
-                <a:solidFill>
-                  <a:srgbClr val="000066"/>
-                </a:solidFill>
-                <a:effectLst/>
-              </a:rPr>
-              <a:t>2 </a:t>
-            </a:r>
-            <a:r>
-              <a:rPr lang="en-US" sz="4267" b="1" dirty="0">
-                <a:solidFill>
-                  <a:srgbClr val="000066"/>
-                </a:solidFill>
-                <a:effectLst/>
-              </a:rPr>
-              <a:t>/ </a:t>
-            </a:r>
-            <a:r>
-              <a:rPr lang="en-US" sz="4267" b="1" dirty="0">
-                <a:solidFill>
-                  <a:srgbClr val="000066"/>
-                </a:solidFill>
-                <a:effectLst/>
-              </a:rPr>
-              <a:t>3 </a:t>
-            </a:r>
-            <a:r>
-              <a:rPr lang="en-US" sz="4267" b="1" dirty="0">
-                <a:solidFill>
-                  <a:srgbClr val="000066"/>
-                </a:solidFill>
-                <a:effectLst/>
-              </a:rPr>
-              <a:t>)</a:t>
+              <a:t>( 2 / 3 )</a:t>
             </a:r>
             <a:endParaRPr lang="vi-VN" sz="4267" b="1" dirty="0">
               <a:solidFill>
@@ -3752,47 +3692,27 @@
                 <a:latin typeface="微軟正黑體"/>
                 <a:ea typeface="微軟正黑體"/>
               </a:rPr>
-              <a:t>封石也歸虛</a:t>
-            </a:r>
-            <a:r>
-              <a:rPr lang="zh-TW" altLang="en-US" sz="6400" b="1" spc="-1" dirty="0">
+              <a:t>封石也歸虛空</a:t>
+            </a:r>
+            <a:r>
+              <a:rPr lang="vi-VN" altLang="zh-TW" sz="6400" b="1" spc="-1" dirty="0">
                 <a:solidFill>
                   <a:srgbClr val="000066"/>
                 </a:solidFill>
                 <a:latin typeface="微軟正黑體"/>
                 <a:ea typeface="微軟正黑體"/>
               </a:rPr>
-              <a:t>空</a:t>
-            </a:r>
-            <a:r>
-              <a:rPr lang="vi-VN" altLang="zh-TW" sz="6400" b="1" spc="-1" dirty="0">
+              <a:t>   </a:t>
+            </a:r>
+            <a:r>
+              <a:rPr lang="zh-TW" altLang="en-US" sz="6400" b="1" spc="-1" dirty="0">
                 <a:solidFill>
                   <a:srgbClr val="000066"/>
                 </a:solidFill>
                 <a:latin typeface="微軟正黑體"/>
                 <a:ea typeface="微軟正黑體"/>
               </a:rPr>
-              <a:t>   </a:t>
-            </a:r>
-            <a:r>
-              <a:rPr lang="zh-TW" altLang="en-US" sz="6400" b="1" spc="-1" dirty="0">
-                <a:solidFill>
-                  <a:srgbClr val="000066"/>
-                </a:solidFill>
-                <a:latin typeface="微軟正黑體"/>
-                <a:ea typeface="微軟正黑體"/>
-              </a:rPr>
-              <a:t>耶</a:t>
-            </a:r>
-            <a:r>
-              <a:rPr lang="zh-TW" altLang="en-US" sz="6400" b="1" spc="-1" dirty="0">
-                <a:solidFill>
-                  <a:srgbClr val="000066"/>
-                </a:solidFill>
-                <a:latin typeface="微軟正黑體"/>
-                <a:ea typeface="微軟正黑體"/>
-              </a:rPr>
-              <a:t>穌我主</a:t>
+              <a:t>耶穌我主</a:t>
             </a:r>
             <a:endParaRPr lang="en-US" altLang="zh-CN" sz="6400" b="1" spc="-1" dirty="0">
               <a:solidFill>
@@ -3979,25 +3899,7 @@
                 </a:solidFill>
                 <a:cs typeface="Arial" panose="020B0604020202020204" pitchFamily="34" charset="0"/>
               </a:rPr>
-              <a:t>Thật canh mả Chúa hư </a:t>
-            </a:r>
-            <a:r>
-              <a:rPr lang="vi-VN" sz="3733" b="1" spc="-1" dirty="0">
-                <a:solidFill>
-                  <a:srgbClr val="660033"/>
-                </a:solidFill>
-                <a:cs typeface="Arial" panose="020B0604020202020204" pitchFamily="34" charset="0"/>
-              </a:rPr>
-              <a:t>không, Chúa </a:t>
-            </a:r>
-            <a:r>
-              <a:rPr lang="vi-VN" sz="3733" b="1" spc="-1" dirty="0">
-                <a:solidFill>
-                  <a:srgbClr val="660033"/>
-                </a:solidFill>
-                <a:cs typeface="Arial" panose="020B0604020202020204" pitchFamily="34" charset="0"/>
-              </a:rPr>
-              <a:t>Jesus tôi</a:t>
+              <a:t>Thật canh mả Chúa hư không, Chúa Jesus tôi</a:t>
             </a:r>
           </a:p>
         </p:txBody>
@@ -4032,43 +3934,7 @@
                 </a:solidFill>
                 <a:effectLst/>
               </a:rPr>
-              <a:t>( </a:t>
-            </a:r>
-            <a:r>
-              <a:rPr lang="en-US" sz="4267" b="1" dirty="0">
-                <a:solidFill>
-                  <a:srgbClr val="000066"/>
-                </a:solidFill>
-                <a:effectLst/>
-              </a:rPr>
-              <a:t>2 </a:t>
-            </a:r>
-            <a:r>
-              <a:rPr lang="en-US" sz="4267" b="1" dirty="0">
-                <a:solidFill>
-                  <a:srgbClr val="000066"/>
-                </a:solidFill>
-                <a:effectLst/>
-              </a:rPr>
-              <a:t>/ </a:t>
-            </a:r>
-            <a:r>
-              <a:rPr lang="en-US" sz="4267" b="1" dirty="0">
-                <a:solidFill>
-                  <a:srgbClr val="000066"/>
-                </a:solidFill>
-                <a:effectLst/>
-              </a:rPr>
-              <a:t>3 </a:t>
-            </a:r>
-            <a:r>
-              <a:rPr lang="en-US" sz="4267" b="1" dirty="0">
-                <a:solidFill>
-                  <a:srgbClr val="000066"/>
-                </a:solidFill>
-                <a:effectLst/>
-              </a:rPr>
-              <a:t>)</a:t>
+              <a:t>( 2 / 3 )</a:t>
             </a:r>
             <a:endParaRPr lang="vi-VN" sz="4267" b="1" dirty="0">
               <a:solidFill>
@@ -4590,43 +4456,7 @@
                 </a:solidFill>
                 <a:cs typeface="Arial" panose="020B0604020202020204" pitchFamily="34" charset="0"/>
               </a:rPr>
-              <a:t>Phục sinh hiển </a:t>
-            </a:r>
-            <a:r>
-              <a:rPr lang="vi-VN" sz="3733" b="1" spc="-1" dirty="0">
-                <a:solidFill>
-                  <a:srgbClr val="660033"/>
-                </a:solidFill>
-                <a:cs typeface="Arial" panose="020B0604020202020204" pitchFamily="34" charset="0"/>
-              </a:rPr>
-              <a:t>vinh </a:t>
-            </a:r>
-            <a:r>
-              <a:rPr lang="vi-VN" sz="3733" b="1" spc="-1" dirty="0">
-                <a:solidFill>
-                  <a:srgbClr val="660033"/>
-                </a:solidFill>
-                <a:cs typeface="Arial" panose="020B0604020202020204" pitchFamily="34" charset="0"/>
-              </a:rPr>
-              <a:t>t</a:t>
-            </a:r>
-            <a:r>
-              <a:rPr lang="vi-VN" sz="3733" b="1" spc="-1" dirty="0">
-                <a:solidFill>
-                  <a:srgbClr val="660033"/>
-                </a:solidFill>
-                <a:cs typeface="Arial" panose="020B0604020202020204" pitchFamily="34" charset="0"/>
-              </a:rPr>
-              <a:t>hắng </a:t>
-            </a:r>
-            <a:r>
-              <a:rPr lang="vi-VN" sz="3733" b="1" spc="-1" dirty="0">
-                <a:solidFill>
-                  <a:srgbClr val="660033"/>
-                </a:solidFill>
-                <a:cs typeface="Arial" panose="020B0604020202020204" pitchFamily="34" charset="0"/>
-              </a:rPr>
-              <a:t>bao quân thù mình</a:t>
+              <a:t>Phục sinh hiển vinh thắng bao quân thù mình</a:t>
             </a:r>
           </a:p>
         </p:txBody>
@@ -4724,17 +4554,7 @@
                 <a:latin typeface="微軟正黑體"/>
                 <a:ea typeface="微軟正黑體"/>
               </a:rPr>
-              <a:t>勝</a:t>
-            </a:r>
-            <a:r>
-              <a:rPr lang="zh-TW" altLang="en-US" sz="6400" b="1" spc="-1" dirty="0">
-                <a:solidFill>
-                  <a:srgbClr val="000066"/>
-                </a:solidFill>
-                <a:latin typeface="微軟正黑體"/>
-                <a:ea typeface="微軟正黑體"/>
-              </a:rPr>
-              <a:t>過黑暗惡魔</a:t>
+              <a:t>勝過黑暗惡魔</a:t>
             </a:r>
             <a:endParaRPr lang="en-US" altLang="zh-CN" sz="6400" b="1" spc="-1" dirty="0">
               <a:solidFill>
@@ -4921,25 +4741,7 @@
                 </a:solidFill>
                 <a:cs typeface="Arial" panose="020B0604020202020204" pitchFamily="34" charset="0"/>
               </a:rPr>
-              <a:t>Ngài phục sinh đem oai quyền </a:t>
-            </a:r>
-            <a:r>
-              <a:rPr lang="vi-VN" sz="3733" b="1" spc="-1" dirty="0">
-                <a:solidFill>
-                  <a:srgbClr val="660033"/>
-                </a:solidFill>
-                <a:cs typeface="Arial" panose="020B0604020202020204" pitchFamily="34" charset="0"/>
-              </a:rPr>
-              <a:t>ra đánh </a:t>
-            </a:r>
-            <a:r>
-              <a:rPr lang="vi-VN" sz="3733" b="1" spc="-1" dirty="0">
-                <a:solidFill>
-                  <a:srgbClr val="660033"/>
-                </a:solidFill>
-                <a:cs typeface="Arial" panose="020B0604020202020204" pitchFamily="34" charset="0"/>
-              </a:rPr>
-              <a:t>tan tử thần</a:t>
+              <a:t>Ngài phục sinh đem oai quyền ra đánh tan tử thần</a:t>
             </a:r>
           </a:p>
         </p:txBody>
@@ -5194,25 +4996,7 @@
                 </a:solidFill>
                 <a:cs typeface="Arial" panose="020B0604020202020204" pitchFamily="34" charset="0"/>
               </a:rPr>
-              <a:t>Và Ngài còn đời </a:t>
-            </a:r>
-            <a:r>
-              <a:rPr lang="vi-VN" sz="3733" b="1" spc="-1" dirty="0">
-                <a:solidFill>
-                  <a:srgbClr val="660033"/>
-                </a:solidFill>
-                <a:cs typeface="Arial" panose="020B0604020202020204" pitchFamily="34" charset="0"/>
-              </a:rPr>
-              <a:t>đời để </a:t>
-            </a:r>
-            <a:r>
-              <a:rPr lang="vi-VN" sz="3733" b="1" spc="-1" dirty="0">
-                <a:solidFill>
-                  <a:srgbClr val="660033"/>
-                </a:solidFill>
-                <a:cs typeface="Arial" panose="020B0604020202020204" pitchFamily="34" charset="0"/>
-              </a:rPr>
-              <a:t>thống trị</a:t>
+              <a:t>Và Ngài còn đời đời để thống trị</a:t>
             </a:r>
             <a:r>
               <a:rPr lang="en-US" sz="3733" b="1" spc="-1" dirty="0">
@@ -5298,17 +5082,7 @@
                 <a:latin typeface="微軟正黑體"/>
                 <a:ea typeface="微軟正黑體"/>
               </a:rPr>
-              <a:t>主復活  主復</a:t>
-            </a:r>
-            <a:r>
-              <a:rPr lang="zh-TW" altLang="en-US" sz="6400" b="1" spc="-1" dirty="0">
-                <a:solidFill>
-                  <a:srgbClr val="000066"/>
-                </a:solidFill>
-                <a:latin typeface="微軟正黑體"/>
-                <a:ea typeface="微軟正黑體"/>
-              </a:rPr>
-              <a:t>活</a:t>
+              <a:t>主復活  主復活</a:t>
             </a:r>
             <a:endParaRPr lang="en-US" altLang="zh-CN" sz="6400" b="1" spc="-1" dirty="0">
               <a:solidFill>
@@ -5659,17 +5433,7 @@
                 <a:latin typeface="微軟正黑體"/>
                 <a:ea typeface="微軟正黑體"/>
               </a:rPr>
-              <a:t>哈</a:t>
-            </a:r>
-            <a:r>
-              <a:rPr lang="zh-TW" altLang="en-US" sz="6400" b="1" spc="-1" dirty="0">
-                <a:solidFill>
-                  <a:srgbClr val="000066"/>
-                </a:solidFill>
-                <a:latin typeface="微軟正黑體"/>
-                <a:ea typeface="微軟正黑體"/>
-              </a:rPr>
-              <a:t>利路亞  主復活</a:t>
+              <a:t>哈利路亞  主復活</a:t>
             </a:r>
             <a:endParaRPr lang="en-US" altLang="zh-CN" sz="6400" b="1" spc="-1" dirty="0">
               <a:solidFill>
@@ -5993,27 +5757,7 @@
                 <a:latin typeface="微軟正黑體"/>
                 <a:ea typeface="微軟正黑體"/>
               </a:rPr>
-              <a:t>死權不能捆主  </a:t>
-            </a:r>
-            <a:r>
-              <a:rPr lang="zh-TW" altLang="en-US" sz="6400" b="1" spc="-1" dirty="0">
-                <a:solidFill>
-                  <a:srgbClr val="000066"/>
-                </a:solidFill>
-                <a:latin typeface="微軟正黑體"/>
-                <a:ea typeface="微軟正黑體"/>
-              </a:rPr>
-              <a:t> 耶</a:t>
-            </a:r>
-            <a:r>
-              <a:rPr lang="zh-TW" altLang="en-US" sz="6400" b="1" spc="-1" dirty="0">
-                <a:solidFill>
-                  <a:srgbClr val="000066"/>
-                </a:solidFill>
-                <a:latin typeface="微軟正黑體"/>
-                <a:ea typeface="微軟正黑體"/>
-              </a:rPr>
-              <a:t>穌我救主</a:t>
+              <a:t>死權不能捆主   耶穌我救主</a:t>
             </a:r>
             <a:endParaRPr lang="en-US" altLang="zh-CN" sz="6400" b="1" spc="-1" dirty="0">
               <a:solidFill>
@@ -6200,25 +5944,7 @@
                 </a:solidFill>
                 <a:cs typeface="Arial" panose="020B0604020202020204" pitchFamily="34" charset="0"/>
               </a:rPr>
-              <a:t>Âm ti giữ Chúa vô </a:t>
-            </a:r>
-            <a:r>
-              <a:rPr lang="vi-VN" sz="3733" b="1" spc="-1" dirty="0">
-                <a:solidFill>
-                  <a:srgbClr val="660033"/>
-                </a:solidFill>
-                <a:cs typeface="Arial" panose="020B0604020202020204" pitchFamily="34" charset="0"/>
-              </a:rPr>
-              <a:t>năng, Jesus </a:t>
-            </a:r>
-            <a:r>
-              <a:rPr lang="vi-VN" sz="3733" b="1" spc="-1" dirty="0">
-                <a:solidFill>
-                  <a:srgbClr val="660033"/>
-                </a:solidFill>
-                <a:cs typeface="Arial" panose="020B0604020202020204" pitchFamily="34" charset="0"/>
-              </a:rPr>
-              <a:t>Cứu Chúa tôi</a:t>
+              <a:t>Âm ti giữ Chúa vô năng, Jesus Cứu Chúa tôi</a:t>
             </a:r>
           </a:p>
         </p:txBody>
@@ -6253,43 +5979,7 @@
                 </a:solidFill>
                 <a:effectLst/>
               </a:rPr>
-              <a:t>( </a:t>
-            </a:r>
-            <a:r>
-              <a:rPr lang="en-US" sz="4267" b="1" dirty="0">
-                <a:solidFill>
-                  <a:srgbClr val="000066"/>
-                </a:solidFill>
-                <a:effectLst/>
-              </a:rPr>
-              <a:t>3 </a:t>
-            </a:r>
-            <a:r>
-              <a:rPr lang="en-US" sz="4267" b="1" dirty="0">
-                <a:solidFill>
-                  <a:srgbClr val="000066"/>
-                </a:solidFill>
-                <a:effectLst/>
-              </a:rPr>
-              <a:t>/ </a:t>
-            </a:r>
-            <a:r>
-              <a:rPr lang="en-US" sz="4267" b="1" dirty="0">
-                <a:solidFill>
-                  <a:srgbClr val="000066"/>
-                </a:solidFill>
-                <a:effectLst/>
-              </a:rPr>
-              <a:t>3 </a:t>
-            </a:r>
-            <a:r>
-              <a:rPr lang="en-US" sz="4267" b="1" dirty="0">
-                <a:solidFill>
-                  <a:srgbClr val="000066"/>
-                </a:solidFill>
-                <a:effectLst/>
-              </a:rPr>
-              <a:t>)</a:t>
+              <a:t>( 3 / 3 )</a:t>
             </a:r>
             <a:endParaRPr lang="vi-VN" sz="4267" b="1" dirty="0">
               <a:solidFill>
@@ -6393,17 +6083,7 @@
                 <a:latin typeface="微軟正黑體"/>
                 <a:ea typeface="微軟正黑體"/>
               </a:rPr>
-              <a:t>耶</a:t>
-            </a:r>
-            <a:r>
-              <a:rPr lang="zh-TW" altLang="en-US" sz="6400" b="1" spc="-1" dirty="0">
-                <a:solidFill>
-                  <a:srgbClr val="000066"/>
-                </a:solidFill>
-                <a:latin typeface="微軟正黑體"/>
-                <a:ea typeface="微軟正黑體"/>
-              </a:rPr>
-              <a:t>穌我主</a:t>
+              <a:t>耶穌我主</a:t>
             </a:r>
             <a:endParaRPr lang="en-US" altLang="zh-CN" sz="6400" b="1" spc="-1" dirty="0">
               <a:solidFill>
@@ -6590,25 +6270,7 @@
                 </a:solidFill>
                 <a:cs typeface="Arial" panose="020B0604020202020204" pitchFamily="34" charset="0"/>
               </a:rPr>
-              <a:t>Ngài đã bẻ khóa tung </a:t>
-            </a:r>
-            <a:r>
-              <a:rPr lang="vi-VN" sz="3733" b="1" spc="-1" dirty="0">
-                <a:solidFill>
-                  <a:srgbClr val="660033"/>
-                </a:solidFill>
-                <a:cs typeface="Arial" panose="020B0604020202020204" pitchFamily="34" charset="0"/>
-              </a:rPr>
-              <a:t>then, Chúa </a:t>
-            </a:r>
-            <a:r>
-              <a:rPr lang="vi-VN" sz="3733" b="1" spc="-1" dirty="0">
-                <a:solidFill>
-                  <a:srgbClr val="660033"/>
-                </a:solidFill>
-                <a:cs typeface="Arial" panose="020B0604020202020204" pitchFamily="34" charset="0"/>
-              </a:rPr>
-              <a:t>Jesus tôi</a:t>
+              <a:t>Ngài đã bẻ khóa tung then, Chúa Jesus tôi</a:t>
             </a:r>
           </a:p>
         </p:txBody>
@@ -6643,43 +6305,7 @@
                 </a:solidFill>
                 <a:effectLst/>
               </a:rPr>
-              <a:t>( </a:t>
-            </a:r>
-            <a:r>
-              <a:rPr lang="en-US" sz="4267" b="1" dirty="0">
-                <a:solidFill>
-                  <a:srgbClr val="000066"/>
-                </a:solidFill>
-                <a:effectLst/>
-              </a:rPr>
-              <a:t>3 </a:t>
-            </a:r>
-            <a:r>
-              <a:rPr lang="en-US" sz="4267" b="1" dirty="0">
-                <a:solidFill>
-                  <a:srgbClr val="000066"/>
-                </a:solidFill>
-                <a:effectLst/>
-              </a:rPr>
-              <a:t>/ </a:t>
-            </a:r>
-            <a:r>
-              <a:rPr lang="en-US" sz="4267" b="1" dirty="0">
-                <a:solidFill>
-                  <a:srgbClr val="000066"/>
-                </a:solidFill>
-                <a:effectLst/>
-              </a:rPr>
-              <a:t>3 </a:t>
-            </a:r>
-            <a:r>
-              <a:rPr lang="en-US" sz="4267" b="1" dirty="0">
-                <a:solidFill>
-                  <a:srgbClr val="000066"/>
-                </a:solidFill>
-                <a:effectLst/>
-              </a:rPr>
-              <a:t>)</a:t>
+              <a:t>( 3 / 3 )</a:t>
             </a:r>
             <a:endParaRPr lang="vi-VN" sz="4267" b="1" dirty="0">
               <a:solidFill>
@@ -6955,37 +6581,7 @@
                 <a:effectLst/>
                 <a:ea typeface="微軟正黑體" pitchFamily="34" charset="-120"/>
               </a:rPr>
-              <a:t>Chôn </a:t>
-            </a:r>
-            <a:r>
-              <a:rPr lang="vi-VN" sz="3733" b="1" dirty="0">
-                <a:solidFill>
-                  <a:srgbClr val="660033"/>
-                </a:solidFill>
-                <a:effectLst/>
-                <a:ea typeface="微軟正黑體" pitchFamily="34" charset="-120"/>
-              </a:rPr>
-              <a:t>sâu dưới mã u </a:t>
-            </a:r>
-            <a:r>
-              <a:rPr lang="vi-VN" sz="3733" b="1" dirty="0">
-                <a:solidFill>
-                  <a:srgbClr val="660033"/>
-                </a:solidFill>
-                <a:effectLst/>
-                <a:ea typeface="微軟正黑體" pitchFamily="34" charset="-120"/>
-              </a:rPr>
-              <a:t>minh, Jesus </a:t>
-            </a:r>
-            <a:r>
-              <a:rPr lang="vi-VN" sz="3733" b="1" dirty="0">
-                <a:solidFill>
-                  <a:srgbClr val="660033"/>
-                </a:solidFill>
-                <a:effectLst/>
-                <a:ea typeface="微軟正黑體" pitchFamily="34" charset="-120"/>
-              </a:rPr>
-              <a:t>Cứu Chúa tôi!</a:t>
+              <a:t>Chôn sâu dưới mã u minh, Jesus Cứu Chúa tôi!</a:t>
             </a:r>
           </a:p>
         </p:txBody>
@@ -7020,25 +6616,7 @@
                 </a:solidFill>
                 <a:effectLst/>
               </a:rPr>
-              <a:t>( 1 / </a:t>
-            </a:r>
-            <a:r>
-              <a:rPr lang="en-US" sz="4267" b="1" dirty="0">
-                <a:solidFill>
-                  <a:srgbClr val="000066"/>
-                </a:solidFill>
-                <a:effectLst/>
-              </a:rPr>
-              <a:t>3 </a:t>
-            </a:r>
-            <a:r>
-              <a:rPr lang="en-US" sz="4267" b="1" dirty="0">
-                <a:solidFill>
-                  <a:srgbClr val="000066"/>
-                </a:solidFill>
-                <a:effectLst/>
-              </a:rPr>
-              <a:t>)</a:t>
+              <a:t>( 1 / 3 )</a:t>
             </a:r>
             <a:endParaRPr lang="vi-VN" sz="4267" b="1" dirty="0">
               <a:solidFill>
@@ -7560,43 +7138,7 @@
                 </a:solidFill>
                 <a:cs typeface="Arial" panose="020B0604020202020204" pitchFamily="34" charset="0"/>
               </a:rPr>
-              <a:t>Phục sinh hiển </a:t>
-            </a:r>
-            <a:r>
-              <a:rPr lang="vi-VN" sz="3733" b="1" spc="-1" dirty="0">
-                <a:solidFill>
-                  <a:srgbClr val="660033"/>
-                </a:solidFill>
-                <a:cs typeface="Arial" panose="020B0604020202020204" pitchFamily="34" charset="0"/>
-              </a:rPr>
-              <a:t>vinh </a:t>
-            </a:r>
-            <a:r>
-              <a:rPr lang="vi-VN" sz="3733" b="1" spc="-1" dirty="0">
-                <a:solidFill>
-                  <a:srgbClr val="660033"/>
-                </a:solidFill>
-                <a:cs typeface="Arial" panose="020B0604020202020204" pitchFamily="34" charset="0"/>
-              </a:rPr>
-              <a:t>t</a:t>
-            </a:r>
-            <a:r>
-              <a:rPr lang="vi-VN" sz="3733" b="1" spc="-1" dirty="0">
-                <a:solidFill>
-                  <a:srgbClr val="660033"/>
-                </a:solidFill>
-                <a:cs typeface="Arial" panose="020B0604020202020204" pitchFamily="34" charset="0"/>
-              </a:rPr>
-              <a:t>hắng </a:t>
-            </a:r>
-            <a:r>
-              <a:rPr lang="vi-VN" sz="3733" b="1" spc="-1" dirty="0">
-                <a:solidFill>
-                  <a:srgbClr val="660033"/>
-                </a:solidFill>
-                <a:cs typeface="Arial" panose="020B0604020202020204" pitchFamily="34" charset="0"/>
-              </a:rPr>
-              <a:t>bao quân thù mình</a:t>
+              <a:t>Phục sinh hiển vinh thắng bao quân thù mình</a:t>
             </a:r>
           </a:p>
         </p:txBody>
@@ -7694,17 +7236,7 @@
                 <a:latin typeface="微軟正黑體"/>
                 <a:ea typeface="微軟正黑體"/>
               </a:rPr>
-              <a:t>勝</a:t>
-            </a:r>
-            <a:r>
-              <a:rPr lang="zh-TW" altLang="en-US" sz="6400" b="1" spc="-1" dirty="0">
-                <a:solidFill>
-                  <a:srgbClr val="000066"/>
-                </a:solidFill>
-                <a:latin typeface="微軟正黑體"/>
-                <a:ea typeface="微軟正黑體"/>
-              </a:rPr>
-              <a:t>過黑暗惡魔</a:t>
+              <a:t>勝過黑暗惡魔</a:t>
             </a:r>
             <a:endParaRPr lang="en-US" altLang="zh-CN" sz="6400" b="1" spc="-1" dirty="0">
               <a:solidFill>
@@ -7891,25 +7423,7 @@
                 </a:solidFill>
                 <a:cs typeface="Arial" panose="020B0604020202020204" pitchFamily="34" charset="0"/>
               </a:rPr>
-              <a:t>Ngài phục sinh đem oai quyền </a:t>
-            </a:r>
-            <a:r>
-              <a:rPr lang="vi-VN" sz="3733" b="1" spc="-1" dirty="0">
-                <a:solidFill>
-                  <a:srgbClr val="660033"/>
-                </a:solidFill>
-                <a:cs typeface="Arial" panose="020B0604020202020204" pitchFamily="34" charset="0"/>
-              </a:rPr>
-              <a:t>ra đánh </a:t>
-            </a:r>
-            <a:r>
-              <a:rPr lang="vi-VN" sz="3733" b="1" spc="-1" dirty="0">
-                <a:solidFill>
-                  <a:srgbClr val="660033"/>
-                </a:solidFill>
-                <a:cs typeface="Arial" panose="020B0604020202020204" pitchFamily="34" charset="0"/>
-              </a:rPr>
-              <a:t>tan tử thần</a:t>
+              <a:t>Ngài phục sinh đem oai quyền ra đánh tan tử thần</a:t>
             </a:r>
           </a:p>
         </p:txBody>
@@ -8164,25 +7678,7 @@
                 </a:solidFill>
                 <a:cs typeface="Arial" panose="020B0604020202020204" pitchFamily="34" charset="0"/>
               </a:rPr>
-              <a:t>Và Ngài còn đời </a:t>
-            </a:r>
-            <a:r>
-              <a:rPr lang="vi-VN" sz="3733" b="1" spc="-1" dirty="0">
-                <a:solidFill>
-                  <a:srgbClr val="660033"/>
-                </a:solidFill>
-                <a:cs typeface="Arial" panose="020B0604020202020204" pitchFamily="34" charset="0"/>
-              </a:rPr>
-              <a:t>đời để </a:t>
-            </a:r>
-            <a:r>
-              <a:rPr lang="vi-VN" sz="3733" b="1" spc="-1" dirty="0">
-                <a:solidFill>
-                  <a:srgbClr val="660033"/>
-                </a:solidFill>
-                <a:cs typeface="Arial" panose="020B0604020202020204" pitchFamily="34" charset="0"/>
-              </a:rPr>
-              <a:t>thống trị</a:t>
+              <a:t>Và Ngài còn đời đời để thống trị</a:t>
             </a:r>
             <a:r>
               <a:rPr lang="en-US" sz="3733" b="1" spc="-1" dirty="0">
@@ -8268,17 +7764,7 @@
                 <a:latin typeface="微軟正黑體"/>
                 <a:ea typeface="微軟正黑體"/>
               </a:rPr>
-              <a:t>主復活  主復</a:t>
-            </a:r>
-            <a:r>
-              <a:rPr lang="zh-TW" altLang="en-US" sz="6400" b="1" spc="-1" dirty="0">
-                <a:solidFill>
-                  <a:srgbClr val="000066"/>
-                </a:solidFill>
-                <a:latin typeface="微軟正黑體"/>
-                <a:ea typeface="微軟正黑體"/>
-              </a:rPr>
-              <a:t>活</a:t>
+              <a:t>主復活  主復活</a:t>
             </a:r>
             <a:endParaRPr lang="en-US" altLang="zh-CN" sz="6400" b="1" spc="-1" dirty="0">
               <a:solidFill>
@@ -8629,17 +8115,7 @@
                 <a:latin typeface="微軟正黑體"/>
                 <a:ea typeface="微軟正黑體"/>
               </a:rPr>
-              <a:t>哈</a:t>
-            </a:r>
-            <a:r>
-              <a:rPr lang="zh-TW" altLang="en-US" sz="6400" b="1" spc="-1" dirty="0">
-                <a:solidFill>
-                  <a:srgbClr val="000066"/>
-                </a:solidFill>
-                <a:latin typeface="微軟正黑體"/>
-                <a:ea typeface="微軟正黑體"/>
-              </a:rPr>
-              <a:t>利路亞  主復活</a:t>
+              <a:t>哈利路亞  主復活</a:t>
             </a:r>
             <a:endParaRPr lang="en-US" altLang="zh-CN" sz="6400" b="1" spc="-1" dirty="0">
               <a:solidFill>
@@ -9240,25 +8716,7 @@
                 </a:solidFill>
                 <a:effectLst/>
               </a:rPr>
-              <a:t>( 1 / </a:t>
-            </a:r>
-            <a:r>
-              <a:rPr lang="en-US" sz="4267" b="1" dirty="0">
-                <a:solidFill>
-                  <a:srgbClr val="000066"/>
-                </a:solidFill>
-                <a:effectLst/>
-              </a:rPr>
-              <a:t>3 </a:t>
-            </a:r>
-            <a:r>
-              <a:rPr lang="en-US" sz="4267" b="1" dirty="0">
-                <a:solidFill>
-                  <a:srgbClr val="000066"/>
-                </a:solidFill>
-                <a:effectLst/>
-              </a:rPr>
-              <a:t>)</a:t>
+              <a:t>( 1 / 3 )</a:t>
             </a:r>
             <a:endParaRPr lang="vi-VN" sz="4267" b="1" dirty="0">
               <a:solidFill>
@@ -9780,43 +9238,7 @@
                 </a:solidFill>
                 <a:cs typeface="Arial" panose="020B0604020202020204" pitchFamily="34" charset="0"/>
               </a:rPr>
-              <a:t>Phục sinh hiển </a:t>
-            </a:r>
-            <a:r>
-              <a:rPr lang="vi-VN" sz="3733" b="1" spc="-1" dirty="0">
-                <a:solidFill>
-                  <a:srgbClr val="660033"/>
-                </a:solidFill>
-                <a:cs typeface="Arial" panose="020B0604020202020204" pitchFamily="34" charset="0"/>
-              </a:rPr>
-              <a:t>vinh </a:t>
-            </a:r>
-            <a:r>
-              <a:rPr lang="vi-VN" sz="3733" b="1" spc="-1" dirty="0">
-                <a:solidFill>
-                  <a:srgbClr val="660033"/>
-                </a:solidFill>
-                <a:cs typeface="Arial" panose="020B0604020202020204" pitchFamily="34" charset="0"/>
-              </a:rPr>
-              <a:t>t</a:t>
-            </a:r>
-            <a:r>
-              <a:rPr lang="vi-VN" sz="3733" b="1" spc="-1" dirty="0">
-                <a:solidFill>
-                  <a:srgbClr val="660033"/>
-                </a:solidFill>
-                <a:cs typeface="Arial" panose="020B0604020202020204" pitchFamily="34" charset="0"/>
-              </a:rPr>
-              <a:t>hắng </a:t>
-            </a:r>
-            <a:r>
-              <a:rPr lang="vi-VN" sz="3733" b="1" spc="-1" dirty="0">
-                <a:solidFill>
-                  <a:srgbClr val="660033"/>
-                </a:solidFill>
-                <a:cs typeface="Arial" panose="020B0604020202020204" pitchFamily="34" charset="0"/>
-              </a:rPr>
-              <a:t>bao quân thù mình</a:t>
+              <a:t>Phục sinh hiển vinh thắng bao quân thù mình</a:t>
             </a:r>
           </a:p>
         </p:txBody>
@@ -9914,17 +9336,7 @@
                 <a:latin typeface="微軟正黑體"/>
                 <a:ea typeface="微軟正黑體"/>
               </a:rPr>
-              <a:t>勝</a:t>
-            </a:r>
-            <a:r>
-              <a:rPr lang="zh-TW" altLang="en-US" sz="6400" b="1" spc="-1" dirty="0">
-                <a:solidFill>
-                  <a:srgbClr val="000066"/>
-                </a:solidFill>
-                <a:latin typeface="微軟正黑體"/>
-                <a:ea typeface="微軟正黑體"/>
-              </a:rPr>
-              <a:t>過黑暗惡魔</a:t>
+              <a:t>勝過黑暗惡魔</a:t>
             </a:r>
             <a:endParaRPr lang="en-US" altLang="zh-CN" sz="6400" b="1" spc="-1" dirty="0">
               <a:solidFill>
@@ -10111,25 +9523,7 @@
                 </a:solidFill>
                 <a:cs typeface="Arial" panose="020B0604020202020204" pitchFamily="34" charset="0"/>
               </a:rPr>
-              <a:t>Ngài phục sinh đem oai quyền </a:t>
-            </a:r>
-            <a:r>
-              <a:rPr lang="vi-VN" sz="3733" b="1" spc="-1" dirty="0">
-                <a:solidFill>
-                  <a:srgbClr val="660033"/>
-                </a:solidFill>
-                <a:cs typeface="Arial" panose="020B0604020202020204" pitchFamily="34" charset="0"/>
-              </a:rPr>
-              <a:t>ra đánh </a:t>
-            </a:r>
-            <a:r>
-              <a:rPr lang="vi-VN" sz="3733" b="1" spc="-1" dirty="0">
-                <a:solidFill>
-                  <a:srgbClr val="660033"/>
-                </a:solidFill>
-                <a:cs typeface="Arial" panose="020B0604020202020204" pitchFamily="34" charset="0"/>
-              </a:rPr>
-              <a:t>tan tử thần</a:t>
+              <a:t>Ngài phục sinh đem oai quyền ra đánh tan tử thần</a:t>
             </a:r>
           </a:p>
         </p:txBody>
@@ -10384,25 +9778,7 @@
                 </a:solidFill>
                 <a:cs typeface="Arial" panose="020B0604020202020204" pitchFamily="34" charset="0"/>
               </a:rPr>
-              <a:t>Và Ngài còn đời </a:t>
-            </a:r>
-            <a:r>
-              <a:rPr lang="vi-VN" sz="3733" b="1" spc="-1" dirty="0">
-                <a:solidFill>
-                  <a:srgbClr val="660033"/>
-                </a:solidFill>
-                <a:cs typeface="Arial" panose="020B0604020202020204" pitchFamily="34" charset="0"/>
-              </a:rPr>
-              <a:t>đời để </a:t>
-            </a:r>
-            <a:r>
-              <a:rPr lang="vi-VN" sz="3733" b="1" spc="-1" dirty="0">
-                <a:solidFill>
-                  <a:srgbClr val="660033"/>
-                </a:solidFill>
-                <a:cs typeface="Arial" panose="020B0604020202020204" pitchFamily="34" charset="0"/>
-              </a:rPr>
-              <a:t>thống trị</a:t>
+              <a:t>Và Ngài còn đời đời để thống trị</a:t>
             </a:r>
             <a:r>
               <a:rPr lang="en-US" sz="3733" b="1" spc="-1" dirty="0">
@@ -10488,17 +9864,7 @@
                 <a:latin typeface="微軟正黑體"/>
                 <a:ea typeface="微軟正黑體"/>
               </a:rPr>
-              <a:t>主復活  主復</a:t>
-            </a:r>
-            <a:r>
-              <a:rPr lang="zh-TW" altLang="en-US" sz="6400" b="1" spc="-1" dirty="0">
-                <a:solidFill>
-                  <a:srgbClr val="000066"/>
-                </a:solidFill>
-                <a:latin typeface="微軟正黑體"/>
-                <a:ea typeface="微軟正黑體"/>
-              </a:rPr>
-              <a:t>活</a:t>
+              <a:t>主復活  主復活</a:t>
             </a:r>
             <a:endParaRPr lang="en-US" altLang="zh-CN" sz="6400" b="1" spc="-1" dirty="0">
               <a:solidFill>
@@ -10849,17 +10215,7 @@
                 <a:latin typeface="微軟正黑體"/>
                 <a:ea typeface="微軟正黑體"/>
               </a:rPr>
-              <a:t>哈</a:t>
-            </a:r>
-            <a:r>
-              <a:rPr lang="zh-TW" altLang="en-US" sz="6400" b="1" spc="-1" dirty="0">
-                <a:solidFill>
-                  <a:srgbClr val="000066"/>
-                </a:solidFill>
-                <a:latin typeface="微軟正黑體"/>
-                <a:ea typeface="微軟正黑體"/>
-              </a:rPr>
-              <a:t>利路亞  主復活</a:t>
+              <a:t>哈利路亞  主復活</a:t>
             </a:r>
             <a:endParaRPr lang="en-US" altLang="zh-CN" sz="6400" b="1" spc="-1" dirty="0">
               <a:solidFill>

</xml_diff>